<commit_message>
Update the report and PPT
</commit_message>
<xml_diff>
--- a/slides/DSAA4012_Serving_Optimization_Study.pptx
+++ b/slides/DSAA4012_Serving_Optimization_Study.pptx
@@ -2,120 +2,25 @@
 <file path=ppt/presentation.xml><?xml version="1.0" encoding="utf-8"?>
 <p:presentation xmlns:p="http://schemas.openxmlformats.org/presentationml/2006/main">
   <p:sldMasterIdLst>
-    <p:sldMasterId xmlns:r="http://schemas.openxmlformats.org/officeDocument/2006/relationships" id="2147483648" r:id="R4389d82e9e8f43cd"/>
+    <p:sldMasterId xmlns:r="http://schemas.openxmlformats.org/officeDocument/2006/relationships" id="2147483648" r:id="R7313d8a3934348c8"/>
   </p:sldMasterIdLst>
   <p:notesMasterIdLst>
-    <p:notesMasterId xmlns:r="http://schemas.openxmlformats.org/officeDocument/2006/relationships" r:id="Re67b902a11704700"/>
+    <p:notesMasterId xmlns:r="http://schemas.openxmlformats.org/officeDocument/2006/relationships" r:id="Rc54f508ae94f485a"/>
   </p:notesMasterIdLst>
   <p:sldIdLst>
-    <p:sldId xmlns:r="http://schemas.openxmlformats.org/officeDocument/2006/relationships" id="256" r:id="R4639302e850348f2"/>
-    <p:sldId xmlns:r="http://schemas.openxmlformats.org/officeDocument/2006/relationships" id="257" r:id="Rb94f4c98f991417a"/>
-    <p:sldId xmlns:r="http://schemas.openxmlformats.org/officeDocument/2006/relationships" id="258" r:id="R3c13695d0b8f4942"/>
-    <p:sldId xmlns:r="http://schemas.openxmlformats.org/officeDocument/2006/relationships" id="259" r:id="Recef35f5c5824169"/>
-    <p:sldId xmlns:r="http://schemas.openxmlformats.org/officeDocument/2006/relationships" id="260" r:id="Rc277353d1af440fd"/>
-    <p:sldId xmlns:r="http://schemas.openxmlformats.org/officeDocument/2006/relationships" id="261" r:id="R5a9fa0159ef84e1a"/>
-    <p:sldId xmlns:r="http://schemas.openxmlformats.org/officeDocument/2006/relationships" id="262" r:id="Re9e810092e6a458b"/>
-    <p:sldId xmlns:r="http://schemas.openxmlformats.org/officeDocument/2006/relationships" id="263" r:id="R803a626095414b0d"/>
-    <p:sldId xmlns:r="http://schemas.openxmlformats.org/officeDocument/2006/relationships" id="264" r:id="Rfc2e8a9c494547d6"/>
-    <p:sldId xmlns:r="http://schemas.openxmlformats.org/officeDocument/2006/relationships" id="265" r:id="R7261ae93cb504ba1"/>
+    <p:sldId xmlns:r="http://schemas.openxmlformats.org/officeDocument/2006/relationships" id="256" r:id="R536d732318df4d06"/>
+    <p:sldId xmlns:r="http://schemas.openxmlformats.org/officeDocument/2006/relationships" id="257" r:id="R8ee6231832984fd4"/>
+    <p:sldId xmlns:r="http://schemas.openxmlformats.org/officeDocument/2006/relationships" id="258" r:id="R82ea7e640b9b4286"/>
+    <p:sldId xmlns:r="http://schemas.openxmlformats.org/officeDocument/2006/relationships" id="259" r:id="Re4b46c80a837449f"/>
+    <p:sldId xmlns:r="http://schemas.openxmlformats.org/officeDocument/2006/relationships" id="260" r:id="R489bb230ebfe4710"/>
+    <p:sldId xmlns:r="http://schemas.openxmlformats.org/officeDocument/2006/relationships" id="261" r:id="R32ae677a670848e4"/>
+    <p:sldId xmlns:r="http://schemas.openxmlformats.org/officeDocument/2006/relationships" id="262" r:id="R4f4416f91dad4d25"/>
+    <p:sldId xmlns:r="http://schemas.openxmlformats.org/officeDocument/2006/relationships" id="263" r:id="R1df1d780a3544a11"/>
+    <p:sldId xmlns:r="http://schemas.openxmlformats.org/officeDocument/2006/relationships" id="264" r:id="Ra88f572387f84afc"/>
+    <p:sldId xmlns:r="http://schemas.openxmlformats.org/officeDocument/2006/relationships" id="265" r:id="R478286592b184f85"/>
   </p:sldIdLst>
   <p:sldSz cx="12192000" cy="6858000"/>
   <p:notesSz cx="6858000" cy="9144000"/>
-  <p:defaultTextStyle>
-    <a:defPPr xmlns:a="http://schemas.openxmlformats.org/drawingml/2006/main">
-      <a:defRPr lang="en-US"/>
-    </a:defPPr>
-    <a:lvl1pPr xmlns:a="http://schemas.openxmlformats.org/drawingml/2006/main" marL="0" indent="0" algn="l" defTabSz="914400">
-      <a:defRPr sz="1800" kern="1200">
-        <a:solidFill>
-          <a:schemeClr val="tx1"/>
-        </a:solidFill>
-        <a:latin typeface="+mn-lt"/>
-        <a:ea typeface="+mn-ea"/>
-        <a:cs typeface="+mn-cs"/>
-      </a:defRPr>
-    </a:lvl1pPr>
-    <a:lvl2pPr xmlns:a="http://schemas.openxmlformats.org/drawingml/2006/main" marL="457200" indent="0" algn="l" defTabSz="914400">
-      <a:defRPr sz="1800" kern="1200">
-        <a:solidFill>
-          <a:schemeClr val="tx1"/>
-        </a:solidFill>
-        <a:latin typeface="+mn-lt"/>
-        <a:ea typeface="+mn-ea"/>
-        <a:cs typeface="+mn-cs"/>
-      </a:defRPr>
-    </a:lvl2pPr>
-    <a:lvl3pPr xmlns:a="http://schemas.openxmlformats.org/drawingml/2006/main" marL="914400" indent="0" algn="l" defTabSz="914400">
-      <a:defRPr sz="1800" kern="1200">
-        <a:solidFill>
-          <a:schemeClr val="tx1"/>
-        </a:solidFill>
-        <a:latin typeface="+mn-lt"/>
-        <a:ea typeface="+mn-ea"/>
-        <a:cs typeface="+mn-cs"/>
-      </a:defRPr>
-    </a:lvl3pPr>
-    <a:lvl4pPr xmlns:a="http://schemas.openxmlformats.org/drawingml/2006/main" marL="1371600" indent="0" algn="l" defTabSz="914400">
-      <a:defRPr sz="1800" kern="1200">
-        <a:solidFill>
-          <a:schemeClr val="tx1"/>
-        </a:solidFill>
-        <a:latin typeface="+mn-lt"/>
-        <a:ea typeface="+mn-ea"/>
-        <a:cs typeface="+mn-cs"/>
-      </a:defRPr>
-    </a:lvl4pPr>
-    <a:lvl5pPr xmlns:a="http://schemas.openxmlformats.org/drawingml/2006/main" marL="1828800" indent="0" algn="l" defTabSz="914400">
-      <a:defRPr sz="1800" kern="1200">
-        <a:solidFill>
-          <a:schemeClr val="tx1"/>
-        </a:solidFill>
-        <a:latin typeface="+mn-lt"/>
-        <a:ea typeface="+mn-ea"/>
-        <a:cs typeface="+mn-cs"/>
-      </a:defRPr>
-    </a:lvl5pPr>
-    <a:lvl6pPr xmlns:a="http://schemas.openxmlformats.org/drawingml/2006/main" marL="2286000" indent="0" algn="l" defTabSz="914400">
-      <a:defRPr sz="1800" kern="1200">
-        <a:solidFill>
-          <a:schemeClr val="tx1"/>
-        </a:solidFill>
-        <a:latin typeface="+mn-lt"/>
-        <a:ea typeface="+mn-ea"/>
-        <a:cs typeface="+mn-cs"/>
-      </a:defRPr>
-    </a:lvl6pPr>
-    <a:lvl7pPr xmlns:a="http://schemas.openxmlformats.org/drawingml/2006/main" marL="2743200" indent="0" algn="l" defTabSz="914400">
-      <a:defRPr sz="1800" kern="1200">
-        <a:solidFill>
-          <a:schemeClr val="tx1"/>
-        </a:solidFill>
-        <a:latin typeface="+mn-lt"/>
-        <a:ea typeface="+mn-ea"/>
-        <a:cs typeface="+mn-cs"/>
-      </a:defRPr>
-    </a:lvl7pPr>
-    <a:lvl8pPr xmlns:a="http://schemas.openxmlformats.org/drawingml/2006/main" marL="3200400" indent="0" algn="l" defTabSz="914400">
-      <a:defRPr sz="1800" kern="1200">
-        <a:solidFill>
-          <a:schemeClr val="tx1"/>
-        </a:solidFill>
-        <a:latin typeface="+mn-lt"/>
-        <a:ea typeface="+mn-ea"/>
-        <a:cs typeface="+mn-cs"/>
-      </a:defRPr>
-    </a:lvl8pPr>
-    <a:lvl9pPr xmlns:a="http://schemas.openxmlformats.org/drawingml/2006/main" marL="3657600" indent="0" algn="l" defTabSz="914400">
-      <a:defRPr sz="1800" kern="1200">
-        <a:solidFill>
-          <a:schemeClr val="tx1"/>
-        </a:solidFill>
-        <a:latin typeface="+mn-lt"/>
-        <a:ea typeface="+mn-ea"/>
-        <a:cs typeface="+mn-cs"/>
-      </a:defRPr>
-    </a:lvl9pPr>
-  </p:defaultTextStyle>
 </p:presentation>
 </file>
 
@@ -544,7 +449,21 @@
         <p:txBody>
           <a:bodyPr xmlns:a="http://schemas.openxmlformats.org/drawingml/2006/main"/>
           <a:lstStyle xmlns:a="http://schemas.openxmlformats.org/drawingml/2006/main"/>
-          <a:p xmlns:a="http://schemas.openxmlformats.org/drawingml/2006/main"/>
+          <a:p xmlns:a="http://schemas.openxmlformats.org/drawingml/2006/main">
+            <a:r>
+              <a:t>[Sources]</a:t>
+            </a:r>
+          </a:p>
+          <a:p xmlns:a="http://schemas.openxmlformats.org/drawingml/2006/main">
+            <a:r>
+              <a:t>- report/latex/report.tex</a:t>
+            </a:r>
+          </a:p>
+          <a:p xmlns:a="http://schemas.openxmlformats.org/drawingml/2006/main">
+            <a:r>
+              <a:t>- results/validation/hardware_dsaa4012_rerun.json</a:t>
+            </a:r>
+          </a:p>
         </p:txBody>
       </p:sp>
       <p:sp>
@@ -610,7 +529,21 @@
         <p:txBody>
           <a:bodyPr xmlns:a="http://schemas.openxmlformats.org/drawingml/2006/main"/>
           <a:lstStyle xmlns:a="http://schemas.openxmlformats.org/drawingml/2006/main"/>
-          <a:p xmlns:a="http://schemas.openxmlformats.org/drawingml/2006/main"/>
+          <a:p xmlns:a="http://schemas.openxmlformats.org/drawingml/2006/main">
+            <a:r>
+              <a:t>[Sources]</a:t>
+            </a:r>
+          </a:p>
+          <a:p xmlns:a="http://schemas.openxmlformats.org/drawingml/2006/main">
+            <a:r>
+              <a:t>- report/latex/report.tex, Sections IV-D through VI</a:t>
+            </a:r>
+          </a:p>
+          <a:p xmlns:a="http://schemas.openxmlformats.org/drawingml/2006/main">
+            <a:r>
+              <a:t>- results/validation/corrected_results_audit.txt</a:t>
+            </a:r>
+          </a:p>
         </p:txBody>
       </p:sp>
       <p:sp>
@@ -676,7 +609,26 @@
         <p:txBody>
           <a:bodyPr xmlns:a="http://schemas.openxmlformats.org/drawingml/2006/main"/>
           <a:lstStyle xmlns:a="http://schemas.openxmlformats.org/drawingml/2006/main"/>
-          <a:p xmlns:a="http://schemas.openxmlformats.org/drawingml/2006/main"/>
+          <a:p xmlns:a="http://schemas.openxmlformats.org/drawingml/2006/main">
+            <a:r>
+              <a:t>[Sources]</a:t>
+            </a:r>
+          </a:p>
+          <a:p xmlns:a="http://schemas.openxmlformats.org/drawingml/2006/main">
+            <a:r>
+              <a:t>- report/latex/report.tex, Sections II-A through II-C</a:t>
+            </a:r>
+          </a:p>
+          <a:p xmlns:a="http://schemas.openxmlformats.org/drawingml/2006/main">
+            <a:r>
+              <a:t>- src/mlsys360/timing.py</a:t>
+            </a:r>
+          </a:p>
+          <a:p xmlns:a="http://schemas.openxmlformats.org/drawingml/2006/main">
+            <a:r>
+              <a:t>- src/mlsys360/decode.py</a:t>
+            </a:r>
+          </a:p>
         </p:txBody>
       </p:sp>
       <p:sp>
@@ -742,7 +694,31 @@
         <p:txBody>
           <a:bodyPr xmlns:a="http://schemas.openxmlformats.org/drawingml/2006/main"/>
           <a:lstStyle xmlns:a="http://schemas.openxmlformats.org/drawingml/2006/main"/>
-          <a:p xmlns:a="http://schemas.openxmlformats.org/drawingml/2006/main"/>
+          <a:p xmlns:a="http://schemas.openxmlformats.org/drawingml/2006/main">
+            <a:r>
+              <a:t>[Sources]</a:t>
+            </a:r>
+          </a:p>
+          <a:p xmlns:a="http://schemas.openxmlformats.org/drawingml/2006/main">
+            <a:r>
+              <a:t>- docs/CORRECTION_AND_RERUN_CHECKLIST.md</a:t>
+            </a:r>
+          </a:p>
+          <a:p xmlns:a="http://schemas.openxmlformats.org/drawingml/2006/main">
+            <a:r>
+              <a:t>- results/validation/corrected_results_audit.txt</a:t>
+            </a:r>
+          </a:p>
+          <a:p xmlns:a="http://schemas.openxmlformats.org/drawingml/2006/main">
+            <a:r>
+              <a:t>- results/processed/cpu_epyc9654_baseline_last_logits.csv</a:t>
+            </a:r>
+          </a:p>
+          <a:p xmlns:a="http://schemas.openxmlformats.org/drawingml/2006/main">
+            <a:r>
+              <a:t>- results/processed/gpu_rtx6000_ada_baseline_last_logits.csv</a:t>
+            </a:r>
+          </a:p>
         </p:txBody>
       </p:sp>
       <p:sp>
@@ -808,7 +784,31 @@
         <p:txBody>
           <a:bodyPr xmlns:a="http://schemas.openxmlformats.org/drawingml/2006/main"/>
           <a:lstStyle xmlns:a="http://schemas.openxmlformats.org/drawingml/2006/main"/>
-          <a:p xmlns:a="http://schemas.openxmlformats.org/drawingml/2006/main"/>
+          <a:p xmlns:a="http://schemas.openxmlformats.org/drawingml/2006/main">
+            <a:r>
+              <a:t>[Sources]</a:t>
+            </a:r>
+          </a:p>
+          <a:p xmlns:a="http://schemas.openxmlformats.org/drawingml/2006/main">
+            <a:r>
+              <a:t>- results/figures/corrected_baseline/tps_heatmap_HKUSTQLAB-6000ADA_cpu_float32_sdpa_cache-on_none_SmolLM2-360M.png</a:t>
+            </a:r>
+          </a:p>
+          <a:p xmlns:a="http://schemas.openxmlformats.org/drawingml/2006/main">
+            <a:r>
+              <a:t>- results/figures/corrected_baseline/tps_heatmap_HKUSTQLAB-6000ADA_cuda_bfloat16_sdpa_cache-on_none_SmolLM2-360M.png</a:t>
+            </a:r>
+          </a:p>
+          <a:p xmlns:a="http://schemas.openxmlformats.org/drawingml/2006/main">
+            <a:r>
+              <a:t>- results/processed/cpu_epyc9654_baseline_last_logits.csv</a:t>
+            </a:r>
+          </a:p>
+          <a:p xmlns:a="http://schemas.openxmlformats.org/drawingml/2006/main">
+            <a:r>
+              <a:t>- results/processed/gpu_rtx6000_ada_baseline_last_logits.csv</a:t>
+            </a:r>
+          </a:p>
         </p:txBody>
       </p:sp>
       <p:sp>
@@ -874,7 +874,26 @@
         <p:txBody>
           <a:bodyPr xmlns:a="http://schemas.openxmlformats.org/drawingml/2006/main"/>
           <a:lstStyle xmlns:a="http://schemas.openxmlformats.org/drawingml/2006/main"/>
-          <a:p xmlns:a="http://schemas.openxmlformats.org/drawingml/2006/main"/>
+          <a:p xmlns:a="http://schemas.openxmlformats.org/drawingml/2006/main">
+            <a:r>
+              <a:t>[Sources]</a:t>
+            </a:r>
+          </a:p>
+          <a:p xmlns:a="http://schemas.openxmlformats.org/drawingml/2006/main">
+            <a:r>
+              <a:t>- results/processed/cpu_epyc9654_baseline_last_logits.csv</a:t>
+            </a:r>
+          </a:p>
+          <a:p xmlns:a="http://schemas.openxmlformats.org/drawingml/2006/main">
+            <a:r>
+              <a:t>- results/processed/gpu_rtx6000_ada_baseline_last_logits.csv</a:t>
+            </a:r>
+          </a:p>
+          <a:p xmlns:a="http://schemas.openxmlformats.org/drawingml/2006/main">
+            <a:r>
+              <a:t>- report/latex/report.tex, Section IV-A</a:t>
+            </a:r>
+          </a:p>
         </p:txBody>
       </p:sp>
       <p:sp>
@@ -940,7 +959,26 @@
         <p:txBody>
           <a:bodyPr xmlns:a="http://schemas.openxmlformats.org/drawingml/2006/main"/>
           <a:lstStyle xmlns:a="http://schemas.openxmlformats.org/drawingml/2006/main"/>
-          <a:p xmlns:a="http://schemas.openxmlformats.org/drawingml/2006/main"/>
+          <a:p xmlns:a="http://schemas.openxmlformats.org/drawingml/2006/main">
+            <a:r>
+              <a:t>[Sources]</a:t>
+            </a:r>
+          </a:p>
+          <a:p xmlns:a="http://schemas.openxmlformats.org/drawingml/2006/main">
+            <a:r>
+              <a:t>- results/processed/cpu_epyc9654_operator_last_logits.csv</a:t>
+            </a:r>
+          </a:p>
+          <a:p xmlns:a="http://schemas.openxmlformats.org/drawingml/2006/main">
+            <a:r>
+              <a:t>- results/processed/gpu_rtx6000_ada_operator_last_logits.csv</a:t>
+            </a:r>
+          </a:p>
+          <a:p xmlns:a="http://schemas.openxmlformats.org/drawingml/2006/main">
+            <a:r>
+              <a:t>- results/validation/gpu_attention_profile.txt</a:t>
+            </a:r>
+          </a:p>
         </p:txBody>
       </p:sp>
       <p:sp>
@@ -1006,7 +1044,26 @@
         <p:txBody>
           <a:bodyPr xmlns:a="http://schemas.openxmlformats.org/drawingml/2006/main"/>
           <a:lstStyle xmlns:a="http://schemas.openxmlformats.org/drawingml/2006/main"/>
-          <a:p xmlns:a="http://schemas.openxmlformats.org/drawingml/2006/main"/>
+          <a:p xmlns:a="http://schemas.openxmlformats.org/drawingml/2006/main">
+            <a:r>
+              <a:t>[Sources]</a:t>
+            </a:r>
+          </a:p>
+          <a:p xmlns:a="http://schemas.openxmlformats.org/drawingml/2006/main">
+            <a:r>
+              <a:t>- results/processed/cpu_epyc9654_cache_off_last_logits.csv</a:t>
+            </a:r>
+          </a:p>
+          <a:p xmlns:a="http://schemas.openxmlformats.org/drawingml/2006/main">
+            <a:r>
+              <a:t>- results/processed/gpu_rtx6000_ada_cache_last_logits.csv</a:t>
+            </a:r>
+          </a:p>
+          <a:p xmlns:a="http://schemas.openxmlformats.org/drawingml/2006/main">
+            <a:r>
+              <a:t>- report/latex/report.tex, Section IV-B</a:t>
+            </a:r>
+          </a:p>
         </p:txBody>
       </p:sp>
       <p:sp>
@@ -1072,7 +1129,31 @@
         <p:txBody>
           <a:bodyPr xmlns:a="http://schemas.openxmlformats.org/drawingml/2006/main"/>
           <a:lstStyle xmlns:a="http://schemas.openxmlformats.org/drawingml/2006/main"/>
-          <a:p xmlns:a="http://schemas.openxmlformats.org/drawingml/2006/main"/>
+          <a:p xmlns:a="http://schemas.openxmlformats.org/drawingml/2006/main">
+            <a:r>
+              <a:t>[Sources]</a:t>
+            </a:r>
+          </a:p>
+          <a:p xmlns:a="http://schemas.openxmlformats.org/drawingml/2006/main">
+            <a:r>
+              <a:t>- results/processed/cpu_epyc9654_quantization_w8a8_last_logits.csv</a:t>
+            </a:r>
+          </a:p>
+          <a:p xmlns:a="http://schemas.openxmlformats.org/drawingml/2006/main">
+            <a:r>
+              <a:t>- results/raw/cpu_epyc9654_quality_arc_easy_w8a8_last_logits.jsonl</a:t>
+            </a:r>
+          </a:p>
+          <a:p xmlns:a="http://schemas.openxmlformats.org/drawingml/2006/main">
+            <a:r>
+              <a:t>- results/raw/gpu_rtx6000_ada_quality_hellaswag.jsonl</a:t>
+            </a:r>
+          </a:p>
+          <a:p xmlns:a="http://schemas.openxmlformats.org/drawingml/2006/main">
+            <a:r>
+              <a:t>- results/validation/gpu_torchao016_profile.txt</a:t>
+            </a:r>
+          </a:p>
         </p:txBody>
       </p:sp>
       <p:sp>
@@ -1138,7 +1219,21 @@
         <p:txBody>
           <a:bodyPr xmlns:a="http://schemas.openxmlformats.org/drawingml/2006/main"/>
           <a:lstStyle xmlns:a="http://schemas.openxmlformats.org/drawingml/2006/main"/>
-          <a:p xmlns:a="http://schemas.openxmlformats.org/drawingml/2006/main"/>
+          <a:p xmlns:a="http://schemas.openxmlformats.org/drawingml/2006/main">
+            <a:r>
+              <a:t>[Sources]</a:t>
+            </a:r>
+          </a:p>
+          <a:p xmlns:a="http://schemas.openxmlformats.org/drawingml/2006/main">
+            <a:r>
+              <a:t>- report/latex/report.tex, Sections IV-A through IV-D</a:t>
+            </a:r>
+          </a:p>
+          <a:p xmlns:a="http://schemas.openxmlformats.org/drawingml/2006/main">
+            <a:r>
+              <a:t>- results/validation/corrected_results_audit.txt</a:t>
+            </a:r>
+          </a:p>
         </p:txBody>
       </p:sp>
       <p:sp>
@@ -1204,7 +1299,7 @@
   </p:cSld>
   <p:clrMap bg1="lt1" tx1="dk1" bg2="lt2" tx2="dk2" accent1="accent1" accent2="accent2" accent3="accent3" accent4="accent4" accent5="accent5" accent6="accent6" hlink="hlink" folHlink="folHlink"/>
   <p:sldLayoutIdLst>
-    <p:sldLayoutId xmlns:r="http://schemas.openxmlformats.org/officeDocument/2006/relationships" id="2147483649" r:id="R94fd3aae17164f78"/>
+    <p:sldLayoutId xmlns:r="http://schemas.openxmlformats.org/officeDocument/2006/relationships" id="2147483649" r:id="R04d6661845014c6b"/>
   </p:sldLayoutIdLst>
   <p:txStyles>
     <p:titleStyle>
@@ -1911,6 +2006,7 @@
     <c:plotArea>
       <c:lineChart>
         <c:grouping val="standard"/>
+        <c:varyColors val="0"/>
         <c:ser>
           <c:idx val="0"/>
           <c:order val="0"/>
@@ -2613,6 +2709,7 @@
           <a:lstStyle xmlns:a="http://schemas.openxmlformats.org/drawingml/2006/main"/>
           <a:p xmlns:a="http://schemas.openxmlformats.org/drawingml/2006/main">
             <a:pPr algn="l">
+              <a:buNone/>
               <a:defRPr sz="1200" b="1">
                 <a:solidFill>
                   <a:srgbClr val="3D8DFF"/>
@@ -2671,6 +2768,7 @@
           <a:lstStyle xmlns:a="http://schemas.openxmlformats.org/drawingml/2006/main"/>
           <a:p xmlns:a="http://schemas.openxmlformats.org/drawingml/2006/main">
             <a:pPr algn="l">
+              <a:buNone/>
               <a:defRPr sz="5850" b="1">
                 <a:solidFill>
                   <a:srgbClr val="111111"/>
@@ -2694,6 +2792,7 @@
           </a:p>
           <a:p xmlns:a="http://schemas.openxmlformats.org/drawingml/2006/main">
             <a:pPr algn="l">
+              <a:buNone/>
               <a:defRPr sz="5850" b="1">
                 <a:solidFill>
                   <a:srgbClr val="111111"/>
@@ -2783,6 +2882,7 @@
           <a:lstStyle xmlns:a="http://schemas.openxmlformats.org/drawingml/2006/main"/>
           <a:p xmlns:a="http://schemas.openxmlformats.org/drawingml/2006/main">
             <a:pPr algn="l">
+              <a:buNone/>
               <a:defRPr sz="2100" b="0">
                 <a:solidFill>
                   <a:srgbClr val="5E6470"/>
@@ -2841,6 +2941,7 @@
           <a:lstStyle xmlns:a="http://schemas.openxmlformats.org/drawingml/2006/main"/>
           <a:p xmlns:a="http://schemas.openxmlformats.org/drawingml/2006/main">
             <a:pPr algn="l">
+              <a:buNone/>
               <a:defRPr sz="1800" b="1">
                 <a:solidFill>
                   <a:srgbClr val="111111"/>
@@ -2899,6 +3000,7 @@
           <a:lstStyle xmlns:a="http://schemas.openxmlformats.org/drawingml/2006/main"/>
           <a:p xmlns:a="http://schemas.openxmlformats.org/drawingml/2006/main">
             <a:pPr algn="l">
+              <a:buNone/>
               <a:defRPr sz="1350" b="0">
                 <a:solidFill>
                   <a:srgbClr val="5E6470"/>
@@ -2967,8 +3069,8 @@
         </p:nvSpPr>
         <p:spPr>
           <a:xfrm xmlns:a="http://schemas.openxmlformats.org/drawingml/2006/main">
-            <a:off x="400050" y="295275"/>
-            <a:ext cx="10810875" cy="838200"/>
+            <a:off x="495300" y="295275"/>
+            <a:ext cx="11296650" cy="838200"/>
           </a:xfrm>
           <a:prstGeom xmlns:a="http://schemas.openxmlformats.org/drawingml/2006/main" prst="rect">
             <a:avLst/>
@@ -2986,6 +3088,7 @@
           <a:lstStyle xmlns:a="http://schemas.openxmlformats.org/drawingml/2006/main"/>
           <a:p xmlns:a="http://schemas.openxmlformats.org/drawingml/2006/main">
             <a:pPr algn="l">
+              <a:buNone/>
               <a:defRPr sz="3450" b="1">
                 <a:solidFill>
                   <a:srgbClr val="111111"/>
@@ -3044,6 +3147,7 @@
           <a:lstStyle xmlns:a="http://schemas.openxmlformats.org/drawingml/2006/main"/>
           <a:p xmlns:a="http://schemas.openxmlformats.org/drawingml/2006/main">
             <a:pPr algn="r">
+              <a:buNone/>
               <a:defRPr sz="1050" b="0">
                 <a:solidFill>
                   <a:srgbClr val="5E6470"/>
@@ -3102,6 +3206,7 @@
           <a:lstStyle xmlns:a="http://schemas.openxmlformats.org/drawingml/2006/main"/>
           <a:p xmlns:a="http://schemas.openxmlformats.org/drawingml/2006/main">
             <a:pPr algn="l">
+              <a:buNone/>
               <a:defRPr sz="1200" b="1">
                 <a:solidFill>
                   <a:srgbClr val="2E9D65"/>
@@ -3193,6 +3298,7 @@
           <a:lstStyle xmlns:a="http://schemas.openxmlformats.org/drawingml/2006/main"/>
           <a:p xmlns:a="http://schemas.openxmlformats.org/drawingml/2006/main">
             <a:pPr algn="l">
+              <a:buNone/>
               <a:defRPr sz="1650" b="1">
                 <a:solidFill>
                   <a:srgbClr val="111111"/>
@@ -3251,6 +3357,7 @@
           <a:lstStyle xmlns:a="http://schemas.openxmlformats.org/drawingml/2006/main"/>
           <a:p xmlns:a="http://schemas.openxmlformats.org/drawingml/2006/main">
             <a:pPr algn="l">
+              <a:buNone/>
               <a:defRPr sz="1425" b="0">
                 <a:solidFill>
                   <a:srgbClr val="5E6470"/>
@@ -3342,6 +3449,7 @@
           <a:lstStyle xmlns:a="http://schemas.openxmlformats.org/drawingml/2006/main"/>
           <a:p xmlns:a="http://schemas.openxmlformats.org/drawingml/2006/main">
             <a:pPr algn="l">
+              <a:buNone/>
               <a:defRPr sz="1650" b="1">
                 <a:solidFill>
                   <a:srgbClr val="111111"/>
@@ -3400,6 +3508,7 @@
           <a:lstStyle xmlns:a="http://schemas.openxmlformats.org/drawingml/2006/main"/>
           <a:p xmlns:a="http://schemas.openxmlformats.org/drawingml/2006/main">
             <a:pPr algn="l">
+              <a:buNone/>
               <a:defRPr sz="1425" b="0">
                 <a:solidFill>
                   <a:srgbClr val="5E6470"/>
@@ -3491,6 +3600,7 @@
           <a:lstStyle xmlns:a="http://schemas.openxmlformats.org/drawingml/2006/main"/>
           <a:p xmlns:a="http://schemas.openxmlformats.org/drawingml/2006/main">
             <a:pPr algn="l">
+              <a:buNone/>
               <a:defRPr sz="1650" b="1">
                 <a:solidFill>
                   <a:srgbClr val="111111"/>
@@ -3549,6 +3659,7 @@
           <a:lstStyle xmlns:a="http://schemas.openxmlformats.org/drawingml/2006/main"/>
           <a:p xmlns:a="http://schemas.openxmlformats.org/drawingml/2006/main">
             <a:pPr algn="l">
+              <a:buNone/>
               <a:defRPr sz="1425" b="0">
                 <a:solidFill>
                   <a:srgbClr val="5E6470"/>
@@ -3607,6 +3718,7 @@
           <a:lstStyle xmlns:a="http://schemas.openxmlformats.org/drawingml/2006/main"/>
           <a:p xmlns:a="http://schemas.openxmlformats.org/drawingml/2006/main">
             <a:pPr algn="l">
+              <a:buNone/>
               <a:defRPr sz="1200" b="1">
                 <a:solidFill>
                   <a:srgbClr val="C77D00"/>
@@ -3698,6 +3810,7 @@
           <a:lstStyle xmlns:a="http://schemas.openxmlformats.org/drawingml/2006/main"/>
           <a:p xmlns:a="http://schemas.openxmlformats.org/drawingml/2006/main">
             <a:pPr algn="l">
+              <a:buNone/>
               <a:defRPr sz="1650" b="1">
                 <a:solidFill>
                   <a:srgbClr val="111111"/>
@@ -3756,6 +3869,7 @@
           <a:lstStyle xmlns:a="http://schemas.openxmlformats.org/drawingml/2006/main"/>
           <a:p xmlns:a="http://schemas.openxmlformats.org/drawingml/2006/main">
             <a:pPr algn="l">
+              <a:buNone/>
               <a:defRPr sz="1425" b="0">
                 <a:solidFill>
                   <a:srgbClr val="5E6470"/>
@@ -3847,6 +3961,7 @@
           <a:lstStyle xmlns:a="http://schemas.openxmlformats.org/drawingml/2006/main"/>
           <a:p xmlns:a="http://schemas.openxmlformats.org/drawingml/2006/main">
             <a:pPr algn="l">
+              <a:buNone/>
               <a:defRPr sz="1650" b="1">
                 <a:solidFill>
                   <a:srgbClr val="111111"/>
@@ -3905,6 +4020,7 @@
           <a:lstStyle xmlns:a="http://schemas.openxmlformats.org/drawingml/2006/main"/>
           <a:p xmlns:a="http://schemas.openxmlformats.org/drawingml/2006/main">
             <a:pPr algn="l">
+              <a:buNone/>
               <a:defRPr sz="1425" b="0">
                 <a:solidFill>
                   <a:srgbClr val="5E6470"/>
@@ -3996,6 +4112,7 @@
           <a:lstStyle xmlns:a="http://schemas.openxmlformats.org/drawingml/2006/main"/>
           <a:p xmlns:a="http://schemas.openxmlformats.org/drawingml/2006/main">
             <a:pPr algn="l">
+              <a:buNone/>
               <a:defRPr sz="1650" b="1">
                 <a:solidFill>
                   <a:srgbClr val="111111"/>
@@ -4054,6 +4171,7 @@
           <a:lstStyle xmlns:a="http://schemas.openxmlformats.org/drawingml/2006/main"/>
           <a:p xmlns:a="http://schemas.openxmlformats.org/drawingml/2006/main">
             <a:pPr algn="l">
+              <a:buNone/>
               <a:defRPr sz="1425" b="0">
                 <a:solidFill>
                   <a:srgbClr val="5E6470"/>
@@ -4143,6 +4261,7 @@
           <a:lstStyle xmlns:a="http://schemas.openxmlformats.org/drawingml/2006/main"/>
           <a:p xmlns:a="http://schemas.openxmlformats.org/drawingml/2006/main">
             <a:pPr algn="l">
+              <a:buNone/>
               <a:defRPr sz="2550" b="1">
                 <a:solidFill>
                   <a:srgbClr val="3D8DFF"/>
@@ -4201,6 +4320,7 @@
           <a:lstStyle xmlns:a="http://schemas.openxmlformats.org/drawingml/2006/main"/>
           <a:p xmlns:a="http://schemas.openxmlformats.org/drawingml/2006/main">
             <a:pPr algn="r">
+              <a:buNone/>
               <a:defRPr sz="1800" b="1">
                 <a:solidFill>
                   <a:srgbClr val="111111"/>
@@ -4288,6 +4408,7 @@
           <a:lstStyle xmlns:a="http://schemas.openxmlformats.org/drawingml/2006/main"/>
           <a:p xmlns:a="http://schemas.openxmlformats.org/drawingml/2006/main">
             <a:pPr algn="l">
+              <a:buNone/>
               <a:defRPr sz="3450" b="1">
                 <a:solidFill>
                   <a:srgbClr val="111111"/>
@@ -4346,6 +4467,7 @@
           <a:lstStyle xmlns:a="http://schemas.openxmlformats.org/drawingml/2006/main"/>
           <a:p xmlns:a="http://schemas.openxmlformats.org/drawingml/2006/main">
             <a:pPr algn="r">
+              <a:buNone/>
               <a:defRPr sz="1050" b="0">
                 <a:solidFill>
                   <a:srgbClr val="5E6470"/>
@@ -4404,6 +4526,7 @@
           <a:lstStyle xmlns:a="http://schemas.openxmlformats.org/drawingml/2006/main"/>
           <a:p xmlns:a="http://schemas.openxmlformats.org/drawingml/2006/main">
             <a:pPr algn="l">
+              <a:buNone/>
               <a:defRPr sz="1725" b="0">
                 <a:solidFill>
                   <a:srgbClr val="5E6470"/>
@@ -4495,6 +4618,7 @@
           <a:lstStyle xmlns:a="http://schemas.openxmlformats.org/drawingml/2006/main"/>
           <a:p xmlns:a="http://schemas.openxmlformats.org/drawingml/2006/main">
             <a:pPr algn="l">
+              <a:buNone/>
               <a:defRPr sz="1200" b="1">
                 <a:solidFill>
                   <a:srgbClr val="3D8DFF"/>
@@ -4553,6 +4677,7 @@
           <a:lstStyle xmlns:a="http://schemas.openxmlformats.org/drawingml/2006/main"/>
           <a:p xmlns:a="http://schemas.openxmlformats.org/drawingml/2006/main">
             <a:pPr algn="l">
+              <a:buNone/>
               <a:defRPr sz="1875" b="1">
                 <a:solidFill>
                   <a:srgbClr val="111111"/>
@@ -4611,6 +4736,7 @@
           <a:lstStyle xmlns:a="http://schemas.openxmlformats.org/drawingml/2006/main"/>
           <a:p xmlns:a="http://schemas.openxmlformats.org/drawingml/2006/main">
             <a:pPr algn="l">
+              <a:buNone/>
               <a:defRPr sz="1350" b="0">
                 <a:solidFill>
                   <a:srgbClr val="5E6470"/>
@@ -4702,6 +4828,7 @@
           <a:lstStyle xmlns:a="http://schemas.openxmlformats.org/drawingml/2006/main"/>
           <a:p xmlns:a="http://schemas.openxmlformats.org/drawingml/2006/main">
             <a:pPr algn="l">
+              <a:buNone/>
               <a:defRPr sz="1200" b="1">
                 <a:solidFill>
                   <a:srgbClr val="6DCBF4"/>
@@ -4760,6 +4887,7 @@
           <a:lstStyle xmlns:a="http://schemas.openxmlformats.org/drawingml/2006/main"/>
           <a:p xmlns:a="http://schemas.openxmlformats.org/drawingml/2006/main">
             <a:pPr algn="l">
+              <a:buNone/>
               <a:defRPr sz="1875" b="1">
                 <a:solidFill>
                   <a:srgbClr val="111111"/>
@@ -4818,6 +4946,7 @@
           <a:lstStyle xmlns:a="http://schemas.openxmlformats.org/drawingml/2006/main"/>
           <a:p xmlns:a="http://schemas.openxmlformats.org/drawingml/2006/main">
             <a:pPr algn="l">
+              <a:buNone/>
               <a:defRPr sz="1350" b="0">
                 <a:solidFill>
                   <a:srgbClr val="5E6470"/>
@@ -4909,6 +5038,7 @@
           <a:lstStyle xmlns:a="http://schemas.openxmlformats.org/drawingml/2006/main"/>
           <a:p xmlns:a="http://schemas.openxmlformats.org/drawingml/2006/main">
             <a:pPr algn="l">
+              <a:buNone/>
               <a:defRPr sz="1200" b="1">
                 <a:solidFill>
                   <a:srgbClr val="2E9D65"/>
@@ -4967,6 +5097,7 @@
           <a:lstStyle xmlns:a="http://schemas.openxmlformats.org/drawingml/2006/main"/>
           <a:p xmlns:a="http://schemas.openxmlformats.org/drawingml/2006/main">
             <a:pPr algn="l">
+              <a:buNone/>
               <a:defRPr sz="1875" b="1">
                 <a:solidFill>
                   <a:srgbClr val="111111"/>
@@ -5025,6 +5156,7 @@
           <a:lstStyle xmlns:a="http://schemas.openxmlformats.org/drawingml/2006/main"/>
           <a:p xmlns:a="http://schemas.openxmlformats.org/drawingml/2006/main">
             <a:pPr algn="l">
+              <a:buNone/>
               <a:defRPr sz="1350" b="0">
                 <a:solidFill>
                   <a:srgbClr val="5E6470"/>
@@ -5116,6 +5248,7 @@
           <a:lstStyle xmlns:a="http://schemas.openxmlformats.org/drawingml/2006/main"/>
           <a:p xmlns:a="http://schemas.openxmlformats.org/drawingml/2006/main">
             <a:pPr algn="l">
+              <a:buNone/>
               <a:defRPr sz="1200" b="1">
                 <a:solidFill>
                   <a:srgbClr val="C77D00"/>
@@ -5174,6 +5307,7 @@
           <a:lstStyle xmlns:a="http://schemas.openxmlformats.org/drawingml/2006/main"/>
           <a:p xmlns:a="http://schemas.openxmlformats.org/drawingml/2006/main">
             <a:pPr algn="l">
+              <a:buNone/>
               <a:defRPr sz="1875" b="1">
                 <a:solidFill>
                   <a:srgbClr val="111111"/>
@@ -5232,6 +5366,7 @@
           <a:lstStyle xmlns:a="http://schemas.openxmlformats.org/drawingml/2006/main"/>
           <a:p xmlns:a="http://schemas.openxmlformats.org/drawingml/2006/main">
             <a:pPr algn="l">
+              <a:buNone/>
               <a:defRPr sz="1350" b="0">
                 <a:solidFill>
                   <a:srgbClr val="5E6470"/>
@@ -5319,6 +5454,7 @@
           <a:lstStyle xmlns:a="http://schemas.openxmlformats.org/drawingml/2006/main"/>
           <a:p xmlns:a="http://schemas.openxmlformats.org/drawingml/2006/main">
             <a:pPr algn="l">
+              <a:buNone/>
               <a:defRPr sz="3450" b="1">
                 <a:solidFill>
                   <a:srgbClr val="111111"/>
@@ -5377,6 +5513,7 @@
           <a:lstStyle xmlns:a="http://schemas.openxmlformats.org/drawingml/2006/main"/>
           <a:p xmlns:a="http://schemas.openxmlformats.org/drawingml/2006/main">
             <a:pPr algn="r">
+              <a:buNone/>
               <a:defRPr sz="1050" b="0">
                 <a:solidFill>
                   <a:srgbClr val="5E6470"/>
@@ -5435,6 +5572,7 @@
           <a:lstStyle xmlns:a="http://schemas.openxmlformats.org/drawingml/2006/main"/>
           <a:p xmlns:a="http://schemas.openxmlformats.org/drawingml/2006/main">
             <a:pPr algn="l">
+              <a:buNone/>
               <a:defRPr sz="1650" b="0">
                 <a:solidFill>
                   <a:srgbClr val="5E6470"/>
@@ -5528,6 +5666,7 @@
           <a:lstStyle xmlns:a="http://schemas.openxmlformats.org/drawingml/2006/main"/>
           <a:p xmlns:a="http://schemas.openxmlformats.org/drawingml/2006/main">
             <a:pPr algn="l">
+              <a:buNone/>
               <a:defRPr sz="1200" b="1">
                 <a:solidFill>
                   <a:srgbClr val="C94B40"/>
@@ -5586,6 +5725,7 @@
           <a:lstStyle xmlns:a="http://schemas.openxmlformats.org/drawingml/2006/main"/>
           <a:p xmlns:a="http://schemas.openxmlformats.org/drawingml/2006/main">
             <a:pPr algn="l">
+              <a:buNone/>
               <a:defRPr sz="2850" b="1">
                 <a:solidFill>
                   <a:srgbClr val="111111"/>
@@ -5644,6 +5784,7 @@
           <a:lstStyle xmlns:a="http://schemas.openxmlformats.org/drawingml/2006/main"/>
           <a:p xmlns:a="http://schemas.openxmlformats.org/drawingml/2006/main">
             <a:pPr algn="l">
+              <a:buNone/>
               <a:defRPr sz="1500" b="0">
                 <a:solidFill>
                   <a:srgbClr val="5E6470"/>
@@ -5737,6 +5878,7 @@
           <a:lstStyle xmlns:a="http://schemas.openxmlformats.org/drawingml/2006/main"/>
           <a:p xmlns:a="http://schemas.openxmlformats.org/drawingml/2006/main">
             <a:pPr algn="l">
+              <a:buNone/>
               <a:defRPr sz="1200" b="1">
                 <a:solidFill>
                   <a:srgbClr val="2E9D65"/>
@@ -5795,6 +5937,7 @@
           <a:lstStyle xmlns:a="http://schemas.openxmlformats.org/drawingml/2006/main"/>
           <a:p xmlns:a="http://schemas.openxmlformats.org/drawingml/2006/main">
             <a:pPr algn="l">
+              <a:buNone/>
               <a:defRPr sz="2850" b="1">
                 <a:solidFill>
                   <a:srgbClr val="111111"/>
@@ -5853,6 +5996,7 @@
           <a:lstStyle xmlns:a="http://schemas.openxmlformats.org/drawingml/2006/main"/>
           <a:p xmlns:a="http://schemas.openxmlformats.org/drawingml/2006/main">
             <a:pPr algn="l">
+              <a:buNone/>
               <a:defRPr sz="1500" b="0">
                 <a:solidFill>
                   <a:srgbClr val="5E6470"/>
@@ -5944,6 +6088,7 @@
           <a:lstStyle xmlns:a="http://schemas.openxmlformats.org/drawingml/2006/main"/>
           <a:p xmlns:a="http://schemas.openxmlformats.org/drawingml/2006/main">
             <a:pPr algn="l">
+              <a:buNone/>
               <a:defRPr sz="3150" b="1">
                 <a:solidFill>
                   <a:srgbClr val="2E9D65"/>
@@ -6002,6 +6147,7 @@
           <a:lstStyle xmlns:a="http://schemas.openxmlformats.org/drawingml/2006/main"/>
           <a:p xmlns:a="http://schemas.openxmlformats.org/drawingml/2006/main">
             <a:pPr algn="l">
+              <a:buNone/>
               <a:defRPr sz="1425" b="0">
                 <a:solidFill>
                   <a:srgbClr val="5E6470"/>
@@ -6093,6 +6239,7 @@
           <a:lstStyle xmlns:a="http://schemas.openxmlformats.org/drawingml/2006/main"/>
           <a:p xmlns:a="http://schemas.openxmlformats.org/drawingml/2006/main">
             <a:pPr algn="l">
+              <a:buNone/>
               <a:defRPr sz="3150" b="1">
                 <a:solidFill>
                   <a:srgbClr val="3D8DFF"/>
@@ -6151,6 +6298,7 @@
           <a:lstStyle xmlns:a="http://schemas.openxmlformats.org/drawingml/2006/main"/>
           <a:p xmlns:a="http://schemas.openxmlformats.org/drawingml/2006/main">
             <a:pPr algn="l">
+              <a:buNone/>
               <a:defRPr sz="1425" b="0">
                 <a:solidFill>
                   <a:srgbClr val="5E6470"/>
@@ -6242,6 +6390,7 @@
           <a:lstStyle xmlns:a="http://schemas.openxmlformats.org/drawingml/2006/main"/>
           <a:p xmlns:a="http://schemas.openxmlformats.org/drawingml/2006/main">
             <a:pPr algn="l">
+              <a:buNone/>
               <a:defRPr sz="3150" b="1">
                 <a:solidFill>
                   <a:srgbClr val="6DCBF4"/>
@@ -6300,6 +6449,7 @@
           <a:lstStyle xmlns:a="http://schemas.openxmlformats.org/drawingml/2006/main"/>
           <a:p xmlns:a="http://schemas.openxmlformats.org/drawingml/2006/main">
             <a:pPr algn="l">
+              <a:buNone/>
               <a:defRPr sz="1425" b="0">
                 <a:solidFill>
                   <a:srgbClr val="5E6470"/>
@@ -6358,6 +6508,7 @@
           <a:lstStyle xmlns:a="http://schemas.openxmlformats.org/drawingml/2006/main"/>
           <a:p xmlns:a="http://schemas.openxmlformats.org/drawingml/2006/main">
             <a:pPr algn="l">
+              <a:buNone/>
               <a:defRPr sz="1950" b="1">
                 <a:solidFill>
                   <a:srgbClr val="3D8DFF"/>
@@ -6445,6 +6596,7 @@
           <a:lstStyle xmlns:a="http://schemas.openxmlformats.org/drawingml/2006/main"/>
           <a:p xmlns:a="http://schemas.openxmlformats.org/drawingml/2006/main">
             <a:pPr algn="l">
+              <a:buNone/>
               <a:defRPr sz="3450" b="1">
                 <a:solidFill>
                   <a:srgbClr val="111111"/>
@@ -6503,6 +6655,7 @@
           <a:lstStyle xmlns:a="http://schemas.openxmlformats.org/drawingml/2006/main"/>
           <a:p xmlns:a="http://schemas.openxmlformats.org/drawingml/2006/main">
             <a:pPr algn="r">
+              <a:buNone/>
               <a:defRPr sz="1050" b="0">
                 <a:solidFill>
                   <a:srgbClr val="5E6470"/>
@@ -6561,6 +6714,7 @@
           <a:lstStyle xmlns:a="http://schemas.openxmlformats.org/drawingml/2006/main"/>
           <a:p xmlns:a="http://schemas.openxmlformats.org/drawingml/2006/main">
             <a:pPr algn="l">
+              <a:buNone/>
               <a:defRPr sz="1200" b="1">
                 <a:solidFill>
                   <a:srgbClr val="3D8DFF"/>
@@ -6619,6 +6773,7 @@
           <a:lstStyle xmlns:a="http://schemas.openxmlformats.org/drawingml/2006/main"/>
           <a:p xmlns:a="http://schemas.openxmlformats.org/drawingml/2006/main">
             <a:pPr algn="l">
+              <a:buNone/>
               <a:defRPr sz="1200" b="1">
                 <a:solidFill>
                   <a:srgbClr val="6DCBF4"/>
@@ -6714,20 +6869,20 @@
       </p:sp>
       <p:pic>
         <p:nvPicPr>
-          <p:cNvPr id="17" name=""/>
+          <p:cNvPr id="20" name=""/>
           <p:cNvPicPr>
             <a:picLocks xmlns:a="http://schemas.openxmlformats.org/drawingml/2006/main" noChangeAspect="1"/>
           </p:cNvPicPr>
           <p:nvPr/>
         </p:nvPicPr>
         <p:blipFill>
-          <a:blip xmlns:r="http://schemas.openxmlformats.org/officeDocument/2006/relationships" xmlns:a="http://schemas.openxmlformats.org/drawingml/2006/main" r:embed="R81253c6071994596"/>
+          <a:blip xmlns:r="http://schemas.openxmlformats.org/officeDocument/2006/relationships" xmlns:a="http://schemas.openxmlformats.org/drawingml/2006/main" r:embed="R5dbc28cac7144c70"/>
           <a:stretch xmlns:a="http://schemas.openxmlformats.org/drawingml/2006/main"/>
         </p:blipFill>
         <p:spPr>
           <a:xfrm xmlns:a="http://schemas.openxmlformats.org/drawingml/2006/main">
-            <a:off x="523875" y="1906905"/>
-            <a:ext cx="5200650" cy="3120390"/>
+            <a:off x="909638" y="2138363"/>
+            <a:ext cx="4429125" cy="2657475"/>
           </a:xfrm>
           <a:prstGeom xmlns:a="http://schemas.openxmlformats.org/drawingml/2006/main" prst="rect">
             <a:avLst/>
@@ -6736,14 +6891,14 @@
       </p:pic>
       <p:pic>
         <p:nvPicPr>
-          <p:cNvPr id="18" name=""/>
+          <p:cNvPr id="21" name=""/>
           <p:cNvPicPr>
             <a:picLocks xmlns:a="http://schemas.openxmlformats.org/drawingml/2006/main" noChangeAspect="1"/>
           </p:cNvPicPr>
           <p:nvPr/>
         </p:nvPicPr>
         <p:blipFill>
-          <a:blip xmlns:r="http://schemas.openxmlformats.org/officeDocument/2006/relationships" xmlns:a="http://schemas.openxmlformats.org/drawingml/2006/main" r:embed="Rfbe8b8dd22c74e25"/>
+          <a:blip xmlns:r="http://schemas.openxmlformats.org/officeDocument/2006/relationships" xmlns:a="http://schemas.openxmlformats.org/drawingml/2006/main" r:embed="Rf6c1c63fa74e4854"/>
           <a:stretch xmlns:a="http://schemas.openxmlformats.org/drawingml/2006/main"/>
         </p:blipFill>
         <p:spPr>
@@ -6791,6 +6946,7 @@
           <a:lstStyle xmlns:a="http://schemas.openxmlformats.org/drawingml/2006/main"/>
           <a:p xmlns:a="http://schemas.openxmlformats.org/drawingml/2006/main">
             <a:pPr algn="l">
+              <a:buNone/>
               <a:defRPr sz="1650" b="1">
                 <a:solidFill>
                   <a:srgbClr val="111111"/>
@@ -6849,6 +7005,7 @@
           <a:lstStyle xmlns:a="http://schemas.openxmlformats.org/drawingml/2006/main"/>
           <a:p xmlns:a="http://schemas.openxmlformats.org/drawingml/2006/main">
             <a:pPr algn="l">
+              <a:buNone/>
               <a:defRPr sz="1650" b="1">
                 <a:solidFill>
                   <a:srgbClr val="111111"/>
@@ -6936,6 +7093,7 @@
           <a:lstStyle xmlns:a="http://schemas.openxmlformats.org/drawingml/2006/main"/>
           <a:p xmlns:a="http://schemas.openxmlformats.org/drawingml/2006/main">
             <a:pPr algn="l">
+              <a:buNone/>
               <a:defRPr sz="3450" b="1">
                 <a:solidFill>
                   <a:srgbClr val="111111"/>
@@ -6994,6 +7152,7 @@
           <a:lstStyle xmlns:a="http://schemas.openxmlformats.org/drawingml/2006/main"/>
           <a:p xmlns:a="http://schemas.openxmlformats.org/drawingml/2006/main">
             <a:pPr algn="r">
+              <a:buNone/>
               <a:defRPr sz="1050" b="0">
                 <a:solidFill>
                   <a:srgbClr val="5E6470"/>
@@ -7052,6 +7211,7 @@
           <a:lstStyle xmlns:a="http://schemas.openxmlformats.org/drawingml/2006/main"/>
           <a:p xmlns:a="http://schemas.openxmlformats.org/drawingml/2006/main">
             <a:pPr algn="l">
+              <a:buNone/>
               <a:defRPr sz="1350" b="0">
                 <a:solidFill>
                   <a:srgbClr val="5E6470"/>
@@ -7077,7 +7237,7 @@
       </p:sp>
       <p:graphicFrame>
         <p:nvGraphicFramePr>
-          <p:cNvPr id="18" name="Chart"/>
+          <p:cNvPr id="20" name="Chart"/>
           <p:cNvGraphicFramePr/>
           <p:nvPr/>
         </p:nvGraphicFramePr>
@@ -7087,7 +7247,7 @@
         </p:xfrm>
         <a:graphic xmlns:a="http://schemas.openxmlformats.org/drawingml/2006/main">
           <a:graphicData uri="http://schemas.openxmlformats.org/drawingml/2006/chart">
-            <c:chart xmlns:r="http://schemas.openxmlformats.org/officeDocument/2006/relationships" xmlns:c="http://schemas.openxmlformats.org/drawingml/2006/chart" r:id="Recfc053ba03044be"/>
+            <c:chart xmlns:r="http://schemas.openxmlformats.org/officeDocument/2006/relationships" xmlns:c="http://schemas.openxmlformats.org/drawingml/2006/chart" r:id="R2784179279844c4b"/>
           </a:graphicData>
         </a:graphic>
       </p:graphicFrame>
@@ -7159,6 +7319,7 @@
           <a:lstStyle xmlns:a="http://schemas.openxmlformats.org/drawingml/2006/main"/>
           <a:p xmlns:a="http://schemas.openxmlformats.org/drawingml/2006/main">
             <a:pPr algn="l">
+              <a:buNone/>
               <a:defRPr sz="2850" b="1">
                 <a:solidFill>
                   <a:srgbClr val="3D8DFF"/>
@@ -7217,6 +7378,7 @@
           <a:lstStyle xmlns:a="http://schemas.openxmlformats.org/drawingml/2006/main"/>
           <a:p xmlns:a="http://schemas.openxmlformats.org/drawingml/2006/main">
             <a:pPr algn="l">
+              <a:buNone/>
               <a:defRPr sz="1500" b="0">
                 <a:solidFill>
                   <a:srgbClr val="5E6470"/>
@@ -7308,6 +7470,7 @@
           <a:lstStyle xmlns:a="http://schemas.openxmlformats.org/drawingml/2006/main"/>
           <a:p xmlns:a="http://schemas.openxmlformats.org/drawingml/2006/main">
             <a:pPr algn="l">
+              <a:buNone/>
               <a:defRPr sz="2850" b="1">
                 <a:solidFill>
                   <a:srgbClr val="6DCBF4"/>
@@ -7366,6 +7529,7 @@
           <a:lstStyle xmlns:a="http://schemas.openxmlformats.org/drawingml/2006/main"/>
           <a:p xmlns:a="http://schemas.openxmlformats.org/drawingml/2006/main">
             <a:pPr algn="l">
+              <a:buNone/>
               <a:defRPr sz="1500" b="0">
                 <a:solidFill>
                   <a:srgbClr val="5E6470"/>
@@ -7457,6 +7621,7 @@
           <a:lstStyle xmlns:a="http://schemas.openxmlformats.org/drawingml/2006/main"/>
           <a:p xmlns:a="http://schemas.openxmlformats.org/drawingml/2006/main">
             <a:pPr algn="l">
+              <a:buNone/>
               <a:defRPr sz="2850" b="1">
                 <a:solidFill>
                   <a:srgbClr val="2E9D65"/>
@@ -7515,6 +7680,7 @@
           <a:lstStyle xmlns:a="http://schemas.openxmlformats.org/drawingml/2006/main"/>
           <a:p xmlns:a="http://schemas.openxmlformats.org/drawingml/2006/main">
             <a:pPr algn="l">
+              <a:buNone/>
               <a:defRPr sz="1500" b="0">
                 <a:solidFill>
                   <a:srgbClr val="5E6470"/>
@@ -7573,6 +7739,7 @@
           <a:lstStyle xmlns:a="http://schemas.openxmlformats.org/drawingml/2006/main"/>
           <a:p xmlns:a="http://schemas.openxmlformats.org/drawingml/2006/main">
             <a:pPr algn="l">
+              <a:buNone/>
               <a:defRPr sz="1275" b="0">
                 <a:solidFill>
                   <a:srgbClr val="5E6470"/>
@@ -7660,6 +7827,7 @@
           <a:lstStyle xmlns:a="http://schemas.openxmlformats.org/drawingml/2006/main"/>
           <a:p xmlns:a="http://schemas.openxmlformats.org/drawingml/2006/main">
             <a:pPr algn="l">
+              <a:buNone/>
               <a:defRPr sz="3450" b="1">
                 <a:solidFill>
                   <a:srgbClr val="111111"/>
@@ -7718,6 +7886,7 @@
           <a:lstStyle xmlns:a="http://schemas.openxmlformats.org/drawingml/2006/main"/>
           <a:p xmlns:a="http://schemas.openxmlformats.org/drawingml/2006/main">
             <a:pPr algn="r">
+              <a:buNone/>
               <a:defRPr sz="1050" b="0">
                 <a:solidFill>
                   <a:srgbClr val="5E6470"/>
@@ -7743,7 +7912,7 @@
       </p:sp>
       <p:graphicFrame>
         <p:nvGraphicFramePr>
-          <p:cNvPr id="16" name="Chart"/>
+          <p:cNvPr id="18" name="Chart"/>
           <p:cNvGraphicFramePr/>
           <p:nvPr/>
         </p:nvGraphicFramePr>
@@ -7753,7 +7922,7 @@
         </p:xfrm>
         <a:graphic xmlns:a="http://schemas.openxmlformats.org/drawingml/2006/main">
           <a:graphicData uri="http://schemas.openxmlformats.org/drawingml/2006/chart">
-            <c:chart xmlns:r="http://schemas.openxmlformats.org/officeDocument/2006/relationships" xmlns:c="http://schemas.openxmlformats.org/drawingml/2006/chart" r:id="R4aee07dd69ab487d"/>
+            <c:chart xmlns:r="http://schemas.openxmlformats.org/officeDocument/2006/relationships" xmlns:c="http://schemas.openxmlformats.org/drawingml/2006/chart" r:id="Ra6e2a5a93ceb4b13"/>
           </a:graphicData>
         </a:graphic>
       </p:graphicFrame>
@@ -7825,6 +7994,7 @@
           <a:lstStyle xmlns:a="http://schemas.openxmlformats.org/drawingml/2006/main"/>
           <a:p xmlns:a="http://schemas.openxmlformats.org/drawingml/2006/main">
             <a:pPr algn="l">
+              <a:buNone/>
               <a:defRPr sz="3150" b="1">
                 <a:solidFill>
                   <a:srgbClr val="6DCBF4"/>
@@ -7883,6 +8053,7 @@
           <a:lstStyle xmlns:a="http://schemas.openxmlformats.org/drawingml/2006/main"/>
           <a:p xmlns:a="http://schemas.openxmlformats.org/drawingml/2006/main">
             <a:pPr algn="l">
+              <a:buNone/>
               <a:defRPr sz="1425" b="0">
                 <a:solidFill>
                   <a:srgbClr val="5E6470"/>
@@ -7974,6 +8145,7 @@
           <a:lstStyle xmlns:a="http://schemas.openxmlformats.org/drawingml/2006/main"/>
           <a:p xmlns:a="http://schemas.openxmlformats.org/drawingml/2006/main">
             <a:pPr algn="l">
+              <a:buNone/>
               <a:defRPr sz="3150" b="1">
                 <a:solidFill>
                   <a:srgbClr val="3D8DFF"/>
@@ -8032,6 +8204,7 @@
           <a:lstStyle xmlns:a="http://schemas.openxmlformats.org/drawingml/2006/main"/>
           <a:p xmlns:a="http://schemas.openxmlformats.org/drawingml/2006/main">
             <a:pPr algn="l">
+              <a:buNone/>
               <a:defRPr sz="1425" b="0">
                 <a:solidFill>
                   <a:srgbClr val="5E6470"/>
@@ -8123,6 +8296,7 @@
           <a:lstStyle xmlns:a="http://schemas.openxmlformats.org/drawingml/2006/main"/>
           <a:p xmlns:a="http://schemas.openxmlformats.org/drawingml/2006/main">
             <a:pPr algn="l">
+              <a:buNone/>
               <a:defRPr sz="1200" b="1">
                 <a:solidFill>
                   <a:srgbClr val="2E9D65"/>
@@ -8181,6 +8355,7 @@
           <a:lstStyle xmlns:a="http://schemas.openxmlformats.org/drawingml/2006/main"/>
           <a:p xmlns:a="http://schemas.openxmlformats.org/drawingml/2006/main">
             <a:pPr algn="l">
+              <a:buNone/>
               <a:defRPr sz="1425" b="1">
                 <a:solidFill>
                   <a:srgbClr val="111111"/>
@@ -8239,6 +8414,7 @@
           <a:lstStyle xmlns:a="http://schemas.openxmlformats.org/drawingml/2006/main"/>
           <a:p xmlns:a="http://schemas.openxmlformats.org/drawingml/2006/main">
             <a:pPr algn="l">
+              <a:buNone/>
               <a:defRPr sz="1350" b="0">
                 <a:solidFill>
                   <a:srgbClr val="5E6470"/>
@@ -8326,6 +8502,7 @@
           <a:lstStyle xmlns:a="http://schemas.openxmlformats.org/drawingml/2006/main"/>
           <a:p xmlns:a="http://schemas.openxmlformats.org/drawingml/2006/main">
             <a:pPr algn="l">
+              <a:buNone/>
               <a:defRPr sz="3450" b="1">
                 <a:solidFill>
                   <a:srgbClr val="111111"/>
@@ -8384,6 +8561,7 @@
           <a:lstStyle xmlns:a="http://schemas.openxmlformats.org/drawingml/2006/main"/>
           <a:p xmlns:a="http://schemas.openxmlformats.org/drawingml/2006/main">
             <a:pPr algn="r">
+              <a:buNone/>
               <a:defRPr sz="1050" b="0">
                 <a:solidFill>
                   <a:srgbClr val="5E6470"/>
@@ -8409,7 +8587,7 @@
       </p:sp>
       <p:graphicFrame>
         <p:nvGraphicFramePr>
-          <p:cNvPr id="15" name="Chart"/>
+          <p:cNvPr id="17" name="Chart"/>
           <p:cNvGraphicFramePr/>
           <p:nvPr/>
         </p:nvGraphicFramePr>
@@ -8419,7 +8597,7 @@
         </p:xfrm>
         <a:graphic xmlns:a="http://schemas.openxmlformats.org/drawingml/2006/main">
           <a:graphicData uri="http://schemas.openxmlformats.org/drawingml/2006/chart">
-            <c:chart xmlns:r="http://schemas.openxmlformats.org/officeDocument/2006/relationships" xmlns:c="http://schemas.openxmlformats.org/drawingml/2006/chart" r:id="R3e2e34a203a04c20"/>
+            <c:chart xmlns:r="http://schemas.openxmlformats.org/officeDocument/2006/relationships" xmlns:c="http://schemas.openxmlformats.org/drawingml/2006/chart" r:id="R516761bbdcab4ebc"/>
           </a:graphicData>
         </a:graphic>
       </p:graphicFrame>
@@ -8493,6 +8671,7 @@
           <a:lstStyle xmlns:a="http://schemas.openxmlformats.org/drawingml/2006/main"/>
           <a:p xmlns:a="http://schemas.openxmlformats.org/drawingml/2006/main">
             <a:pPr algn="l">
+              <a:buNone/>
               <a:defRPr sz="1200" b="1">
                 <a:solidFill>
                   <a:srgbClr val="C77D00"/>
@@ -8551,6 +8730,7 @@
           <a:lstStyle xmlns:a="http://schemas.openxmlformats.org/drawingml/2006/main"/>
           <a:p xmlns:a="http://schemas.openxmlformats.org/drawingml/2006/main">
             <a:pPr algn="l">
+              <a:buNone/>
               <a:defRPr sz="2175" b="1">
                 <a:solidFill>
                   <a:srgbClr val="111111"/>
@@ -8609,6 +8789,7 @@
           <a:lstStyle xmlns:a="http://schemas.openxmlformats.org/drawingml/2006/main"/>
           <a:p xmlns:a="http://schemas.openxmlformats.org/drawingml/2006/main">
             <a:pPr algn="l">
+              <a:buNone/>
               <a:defRPr sz="1350" b="0">
                 <a:solidFill>
                   <a:srgbClr val="5E6470"/>
@@ -8702,6 +8883,7 @@
           <a:lstStyle xmlns:a="http://schemas.openxmlformats.org/drawingml/2006/main"/>
           <a:p xmlns:a="http://schemas.openxmlformats.org/drawingml/2006/main">
             <a:pPr algn="l">
+              <a:buNone/>
               <a:defRPr sz="1200" b="1">
                 <a:solidFill>
                   <a:srgbClr val="2E9D65"/>
@@ -8760,6 +8942,7 @@
           <a:lstStyle xmlns:a="http://schemas.openxmlformats.org/drawingml/2006/main"/>
           <a:p xmlns:a="http://schemas.openxmlformats.org/drawingml/2006/main">
             <a:pPr algn="l">
+              <a:buNone/>
               <a:defRPr sz="2175" b="1">
                 <a:solidFill>
                   <a:srgbClr val="111111"/>
@@ -8818,6 +9001,7 @@
           <a:lstStyle xmlns:a="http://schemas.openxmlformats.org/drawingml/2006/main"/>
           <a:p xmlns:a="http://schemas.openxmlformats.org/drawingml/2006/main">
             <a:pPr algn="l">
+              <a:buNone/>
               <a:defRPr sz="1350" b="0">
                 <a:solidFill>
                   <a:srgbClr val="5E6470"/>
@@ -8876,6 +9060,7 @@
           <a:lstStyle xmlns:a="http://schemas.openxmlformats.org/drawingml/2006/main"/>
           <a:p xmlns:a="http://schemas.openxmlformats.org/drawingml/2006/main">
             <a:pPr algn="l">
+              <a:buNone/>
               <a:defRPr sz="1275" b="0">
                 <a:solidFill>
                   <a:srgbClr val="5E6470"/>
@@ -8963,6 +9148,7 @@
           <a:lstStyle xmlns:a="http://schemas.openxmlformats.org/drawingml/2006/main"/>
           <a:p xmlns:a="http://schemas.openxmlformats.org/drawingml/2006/main">
             <a:pPr algn="l">
+              <a:buNone/>
               <a:defRPr sz="3450" b="1">
                 <a:solidFill>
                   <a:srgbClr val="111111"/>
@@ -9021,6 +9207,7 @@
           <a:lstStyle xmlns:a="http://schemas.openxmlformats.org/drawingml/2006/main"/>
           <a:p xmlns:a="http://schemas.openxmlformats.org/drawingml/2006/main">
             <a:pPr algn="r">
+              <a:buNone/>
               <a:defRPr sz="1050" b="0">
                 <a:solidFill>
                   <a:srgbClr val="5E6470"/>
@@ -9046,7 +9233,7 @@
       </p:sp>
       <p:graphicFrame>
         <p:nvGraphicFramePr>
-          <p:cNvPr id="16" name="Chart"/>
+          <p:cNvPr id="18" name="Chart"/>
           <p:cNvGraphicFramePr/>
           <p:nvPr/>
         </p:nvGraphicFramePr>
@@ -9056,7 +9243,7 @@
         </p:xfrm>
         <a:graphic xmlns:a="http://schemas.openxmlformats.org/drawingml/2006/main">
           <a:graphicData uri="http://schemas.openxmlformats.org/drawingml/2006/chart">
-            <c:chart xmlns:r="http://schemas.openxmlformats.org/officeDocument/2006/relationships" xmlns:c="http://schemas.openxmlformats.org/drawingml/2006/chart" r:id="Raf6b9368f7004353"/>
+            <c:chart xmlns:r="http://schemas.openxmlformats.org/officeDocument/2006/relationships" xmlns:c="http://schemas.openxmlformats.org/drawingml/2006/chart" r:id="Rfceca8f699aa4871"/>
           </a:graphicData>
         </a:graphic>
       </p:graphicFrame>
@@ -9128,6 +9315,7 @@
           <a:lstStyle xmlns:a="http://schemas.openxmlformats.org/drawingml/2006/main"/>
           <a:p xmlns:a="http://schemas.openxmlformats.org/drawingml/2006/main">
             <a:pPr algn="l">
+              <a:buNone/>
               <a:defRPr sz="3150" b="1">
                 <a:solidFill>
                   <a:srgbClr val="C94B40"/>
@@ -9186,6 +9374,7 @@
           <a:lstStyle xmlns:a="http://schemas.openxmlformats.org/drawingml/2006/main"/>
           <a:p xmlns:a="http://schemas.openxmlformats.org/drawingml/2006/main">
             <a:pPr algn="l">
+              <a:buNone/>
               <a:defRPr sz="1425" b="0">
                 <a:solidFill>
                   <a:srgbClr val="5E6470"/>
@@ -9277,6 +9466,7 @@
           <a:lstStyle xmlns:a="http://schemas.openxmlformats.org/drawingml/2006/main"/>
           <a:p xmlns:a="http://schemas.openxmlformats.org/drawingml/2006/main">
             <a:pPr algn="l">
+              <a:buNone/>
               <a:defRPr sz="3150" b="1">
                 <a:solidFill>
                   <a:srgbClr val="C94B40"/>
@@ -9335,6 +9525,7 @@
           <a:lstStyle xmlns:a="http://schemas.openxmlformats.org/drawingml/2006/main"/>
           <a:p xmlns:a="http://schemas.openxmlformats.org/drawingml/2006/main">
             <a:pPr algn="l">
+              <a:buNone/>
               <a:defRPr sz="1425" b="0">
                 <a:solidFill>
                   <a:srgbClr val="5E6470"/>
@@ -9426,6 +9617,7 @@
           <a:lstStyle xmlns:a="http://schemas.openxmlformats.org/drawingml/2006/main"/>
           <a:p xmlns:a="http://schemas.openxmlformats.org/drawingml/2006/main">
             <a:pPr algn="l">
+              <a:buNone/>
               <a:defRPr sz="1200" b="1">
                 <a:solidFill>
                   <a:srgbClr val="C77D00"/>
@@ -9484,6 +9676,7 @@
           <a:lstStyle xmlns:a="http://schemas.openxmlformats.org/drawingml/2006/main"/>
           <a:p xmlns:a="http://schemas.openxmlformats.org/drawingml/2006/main">
             <a:pPr algn="l">
+              <a:buNone/>
               <a:defRPr sz="1425" b="1">
                 <a:solidFill>
                   <a:srgbClr val="111111"/>
@@ -9542,6 +9735,7 @@
           <a:lstStyle xmlns:a="http://schemas.openxmlformats.org/drawingml/2006/main"/>
           <a:p xmlns:a="http://schemas.openxmlformats.org/drawingml/2006/main">
             <a:pPr algn="l">
+              <a:buNone/>
               <a:defRPr sz="1350" b="0">
                 <a:solidFill>
                   <a:srgbClr val="5E6470"/>
@@ -9629,6 +9823,7 @@
           <a:lstStyle xmlns:a="http://schemas.openxmlformats.org/drawingml/2006/main"/>
           <a:p xmlns:a="http://schemas.openxmlformats.org/drawingml/2006/main">
             <a:pPr algn="l">
+              <a:buNone/>
               <a:defRPr sz="3450" b="1">
                 <a:solidFill>
                   <a:srgbClr val="111111"/>
@@ -9687,6 +9882,7 @@
           <a:lstStyle xmlns:a="http://schemas.openxmlformats.org/drawingml/2006/main"/>
           <a:p xmlns:a="http://schemas.openxmlformats.org/drawingml/2006/main">
             <a:pPr algn="r">
+              <a:buNone/>
               <a:defRPr sz="1050" b="0">
                 <a:solidFill>
                   <a:srgbClr val="5E6470"/>
@@ -9745,6 +9941,7 @@
           <a:lstStyle xmlns:a="http://schemas.openxmlformats.org/drawingml/2006/main"/>
           <a:p xmlns:a="http://schemas.openxmlformats.org/drawingml/2006/main">
             <a:pPr algn="l">
+              <a:buNone/>
               <a:defRPr sz="1350" b="0">
                 <a:solidFill>
                   <a:srgbClr val="5E6470"/>
@@ -9836,6 +10033,7 @@
           <a:lstStyle xmlns:a="http://schemas.openxmlformats.org/drawingml/2006/main"/>
           <a:p xmlns:a="http://schemas.openxmlformats.org/drawingml/2006/main">
             <a:pPr algn="l">
+              <a:buNone/>
               <a:defRPr sz="1200" b="1">
                 <a:solidFill>
                   <a:srgbClr val="C77D00"/>
@@ -9894,6 +10092,7 @@
           <a:lstStyle xmlns:a="http://schemas.openxmlformats.org/drawingml/2006/main"/>
           <a:p xmlns:a="http://schemas.openxmlformats.org/drawingml/2006/main">
             <a:pPr algn="l">
+              <a:buNone/>
               <a:defRPr sz="2100" b="1">
                 <a:solidFill>
                   <a:srgbClr val="111111"/>
@@ -9952,6 +10151,7 @@
           <a:lstStyle xmlns:a="http://schemas.openxmlformats.org/drawingml/2006/main"/>
           <a:p xmlns:a="http://schemas.openxmlformats.org/drawingml/2006/main">
             <a:pPr algn="l">
+              <a:buNone/>
               <a:defRPr sz="1425" b="0">
                 <a:solidFill>
                   <a:srgbClr val="5E6470"/>
@@ -10043,6 +10243,7 @@
           <a:lstStyle xmlns:a="http://schemas.openxmlformats.org/drawingml/2006/main"/>
           <a:p xmlns:a="http://schemas.openxmlformats.org/drawingml/2006/main">
             <a:pPr algn="l">
+              <a:buNone/>
               <a:defRPr sz="1200" b="1">
                 <a:solidFill>
                   <a:srgbClr val="3D8DFF"/>
@@ -10101,6 +10302,7 @@
           <a:lstStyle xmlns:a="http://schemas.openxmlformats.org/drawingml/2006/main"/>
           <a:p xmlns:a="http://schemas.openxmlformats.org/drawingml/2006/main">
             <a:pPr algn="l">
+              <a:buNone/>
               <a:defRPr sz="2100" b="1">
                 <a:solidFill>
                   <a:srgbClr val="111111"/>
@@ -10159,6 +10361,7 @@
           <a:lstStyle xmlns:a="http://schemas.openxmlformats.org/drawingml/2006/main"/>
           <a:p xmlns:a="http://schemas.openxmlformats.org/drawingml/2006/main">
             <a:pPr algn="l">
+              <a:buNone/>
               <a:defRPr sz="1425" b="0">
                 <a:solidFill>
                   <a:srgbClr val="5E6470"/>
@@ -10250,6 +10453,7 @@
           <a:lstStyle xmlns:a="http://schemas.openxmlformats.org/drawingml/2006/main"/>
           <a:p xmlns:a="http://schemas.openxmlformats.org/drawingml/2006/main">
             <a:pPr algn="l">
+              <a:buNone/>
               <a:defRPr sz="1200" b="1">
                 <a:solidFill>
                   <a:srgbClr val="6DCBF4"/>
@@ -10308,6 +10512,7 @@
           <a:lstStyle xmlns:a="http://schemas.openxmlformats.org/drawingml/2006/main"/>
           <a:p xmlns:a="http://schemas.openxmlformats.org/drawingml/2006/main">
             <a:pPr algn="l">
+              <a:buNone/>
               <a:defRPr sz="2100" b="1">
                 <a:solidFill>
                   <a:srgbClr val="111111"/>
@@ -10366,6 +10571,7 @@
           <a:lstStyle xmlns:a="http://schemas.openxmlformats.org/drawingml/2006/main"/>
           <a:p xmlns:a="http://schemas.openxmlformats.org/drawingml/2006/main">
             <a:pPr algn="l">
+              <a:buNone/>
               <a:defRPr sz="1425" b="0">
                 <a:solidFill>
                   <a:srgbClr val="5E6470"/>
@@ -10457,6 +10663,7 @@
           <a:lstStyle xmlns:a="http://schemas.openxmlformats.org/drawingml/2006/main"/>
           <a:p xmlns:a="http://schemas.openxmlformats.org/drawingml/2006/main">
             <a:pPr algn="l">
+              <a:buNone/>
               <a:defRPr sz="1200" b="1">
                 <a:solidFill>
                   <a:srgbClr val="2E9D65"/>
@@ -10515,6 +10722,7 @@
           <a:lstStyle xmlns:a="http://schemas.openxmlformats.org/drawingml/2006/main"/>
           <a:p xmlns:a="http://schemas.openxmlformats.org/drawingml/2006/main">
             <a:pPr algn="l">
+              <a:buNone/>
               <a:defRPr sz="2100" b="1">
                 <a:solidFill>
                   <a:srgbClr val="111111"/>
@@ -10573,6 +10781,7 @@
           <a:lstStyle xmlns:a="http://schemas.openxmlformats.org/drawingml/2006/main"/>
           <a:p xmlns:a="http://schemas.openxmlformats.org/drawingml/2006/main">
             <a:pPr algn="l">
+              <a:buNone/>
               <a:defRPr sz="1425" b="0">
                 <a:solidFill>
                   <a:srgbClr val="5E6470"/>

</xml_diff>